<commit_message>
deck v3.3: +10 образов по всему деку (Spider-Man, Gandalf, Stonks, Drake→X-doubt, Two Buttons, xkcd) — 24/47 media-rich (#183)
Co-Authored-By: Claude Fable 5 <noreply@anthropic.com>
Claude-Session: https://claude.ai/code/session_011eUQ6Npp6o8xju5r4zQPac
</commit_message>
<xml_diff>
--- a/library/lectures/lec-02/rendered/lec-02.pptx
+++ b/library/lectures/lec-02/rendered/lec-02.pptx
@@ -8767,11 +8767,11 @@
         <p:spPr>
           <a:xfrm>
             <a:off x="502920" y="1481328"/>
-            <a:ext cx="5486400" cy="3017520"/>
+            <a:ext cx="5486400" cy="3383280"/>
           </a:xfrm>
           <a:prstGeom prst="roundRect">
             <a:avLst>
-              <a:gd name="adj" fmla="val 10101"/>
+              <a:gd name="adj" fmla="val 9009"/>
             </a:avLst>
           </a:prstGeom>
           <a:solidFill>
@@ -8985,11 +8985,11 @@
         <p:spPr>
           <a:xfrm>
             <a:off x="6217920" y="1481328"/>
-            <a:ext cx="5486400" cy="3017520"/>
+            <a:ext cx="5486400" cy="3383280"/>
           </a:xfrm>
           <a:prstGeom prst="roundRect">
             <a:avLst>
-              <a:gd name="adj" fmla="val 10101"/>
+              <a:gd name="adj" fmla="val 9009"/>
             </a:avLst>
           </a:prstGeom>
           <a:solidFill>
@@ -9148,15 +9148,39 @@
           </a:p>
         </p:txBody>
       </p:sp>
-      <p:sp>
-        <p:nvSpPr>
-          <p:cNvPr id="10" name="TextBox 9"/>
+      <p:pic>
+        <p:nvPicPr>
+          <p:cNvPr id="10" name="Picture 9" descr="mathlady-tokens.jpg"/>
+          <p:cNvPicPr>
+            <a:picLocks noChangeAspect="1"/>
+          </p:cNvPicPr>
+          <p:nvPr/>
+        </p:nvPicPr>
+        <p:blipFill>
+          <a:blip r:embed="rId2"/>
+          <a:stretch>
+            <a:fillRect/>
+          </a:stretch>
+        </p:blipFill>
+        <p:spPr>
+          <a:xfrm>
+            <a:off x="7855641" y="3310128"/>
+            <a:ext cx="2210957" cy="1444752"/>
+          </a:xfrm>
+          <a:prstGeom prst="rect">
+            <a:avLst/>
+          </a:prstGeom>
+        </p:spPr>
+      </p:pic>
+      <p:sp>
+        <p:nvSpPr>
+          <p:cNvPr id="11" name="TextBox 10"/>
           <p:cNvSpPr txBox="1"/>
           <p:nvPr/>
         </p:nvSpPr>
         <p:spPr>
           <a:xfrm>
-            <a:off x="502920" y="4663440"/>
+            <a:off x="502920" y="4974336"/>
             <a:ext cx="3657600" cy="292608"/>
           </a:xfrm>
           <a:prstGeom prst="rect">
@@ -9189,13 +9213,13 @@
       </p:sp>
       <p:sp>
         <p:nvSpPr>
-          <p:cNvPr id="11" name="Rounded Rectangle 10"/>
+          <p:cNvPr id="12" name="Rounded Rectangle 11"/>
           <p:cNvSpPr/>
           <p:nvPr/>
         </p:nvSpPr>
         <p:spPr>
           <a:xfrm>
-            <a:off x="495147" y="4983480"/>
+            <a:off x="495147" y="5285232"/>
             <a:ext cx="3611880" cy="685800"/>
           </a:xfrm>
           <a:prstGeom prst="roundRect">
@@ -9237,13 +9261,13 @@
       </p:sp>
       <p:sp>
         <p:nvSpPr>
-          <p:cNvPr id="12" name="TextBox 11"/>
+          <p:cNvPr id="13" name="TextBox 12"/>
           <p:cNvSpPr txBox="1"/>
           <p:nvPr/>
         </p:nvSpPr>
         <p:spPr>
           <a:xfrm>
-            <a:off x="632307" y="5038344"/>
+            <a:off x="632307" y="5340096"/>
             <a:ext cx="3337560" cy="566928"/>
           </a:xfrm>
           <a:prstGeom prst="rect">
@@ -9276,13 +9300,13 @@
       </p:sp>
       <p:sp>
         <p:nvSpPr>
-          <p:cNvPr id="13" name="Rounded Rectangle 12"/>
+          <p:cNvPr id="14" name="Rounded Rectangle 13"/>
           <p:cNvSpPr/>
           <p:nvPr/>
         </p:nvSpPr>
         <p:spPr>
           <a:xfrm>
-            <a:off x="4289907" y="4983480"/>
+            <a:off x="4289907" y="5285232"/>
             <a:ext cx="3611880" cy="685800"/>
           </a:xfrm>
           <a:prstGeom prst="roundRect">
@@ -9324,13 +9348,13 @@
       </p:sp>
       <p:sp>
         <p:nvSpPr>
-          <p:cNvPr id="14" name="TextBox 13"/>
+          <p:cNvPr id="15" name="TextBox 14"/>
           <p:cNvSpPr txBox="1"/>
           <p:nvPr/>
         </p:nvSpPr>
         <p:spPr>
           <a:xfrm>
-            <a:off x="4427067" y="5038344"/>
+            <a:off x="4427067" y="5340096"/>
             <a:ext cx="3337560" cy="566928"/>
           </a:xfrm>
           <a:prstGeom prst="rect">
@@ -9363,13 +9387,13 @@
       </p:sp>
       <p:sp>
         <p:nvSpPr>
-          <p:cNvPr id="15" name="Rounded Rectangle 14"/>
+          <p:cNvPr id="16" name="Rounded Rectangle 15"/>
           <p:cNvSpPr/>
           <p:nvPr/>
         </p:nvSpPr>
         <p:spPr>
           <a:xfrm>
-            <a:off x="8084667" y="4983480"/>
+            <a:off x="8084667" y="5285232"/>
             <a:ext cx="3611880" cy="685800"/>
           </a:xfrm>
           <a:prstGeom prst="roundRect">
@@ -9411,13 +9435,13 @@
       </p:sp>
       <p:sp>
         <p:nvSpPr>
-          <p:cNvPr id="16" name="TextBox 15"/>
+          <p:cNvPr id="17" name="TextBox 16"/>
           <p:cNvSpPr txBox="1"/>
           <p:nvPr/>
         </p:nvSpPr>
         <p:spPr>
           <a:xfrm>
-            <a:off x="8221827" y="5038344"/>
+            <a:off x="8221827" y="5340096"/>
             <a:ext cx="3337560" cy="566928"/>
           </a:xfrm>
           <a:prstGeom prst="rect">
@@ -9450,13 +9474,13 @@
       </p:sp>
       <p:sp>
         <p:nvSpPr>
-          <p:cNvPr id="17" name="TextBox 16"/>
+          <p:cNvPr id="18" name="TextBox 17"/>
           <p:cNvSpPr txBox="1"/>
           <p:nvPr/>
         </p:nvSpPr>
         <p:spPr>
           <a:xfrm>
-            <a:off x="502920" y="5806440"/>
+            <a:off x="502920" y="6089904"/>
             <a:ext cx="11201400" cy="502920"/>
           </a:xfrm>
           <a:prstGeom prst="rect">
@@ -9489,7 +9513,7 @@
       </p:sp>
       <p:sp>
         <p:nvSpPr>
-          <p:cNvPr id="18" name="TextBox 17"/>
+          <p:cNvPr id="19" name="TextBox 18"/>
           <p:cNvSpPr txBox="1"/>
           <p:nvPr/>
         </p:nvSpPr>
@@ -10559,11 +10583,11 @@
         <p:spPr>
           <a:xfrm>
             <a:off x="7452360" y="1554480"/>
-            <a:ext cx="4251960" cy="2011680"/>
+            <a:ext cx="4251960" cy="2880360"/>
           </a:xfrm>
           <a:prstGeom prst="roundRect">
             <a:avLst>
-              <a:gd name="adj" fmla="val 15151"/>
+              <a:gd name="adj" fmla="val 10582"/>
             </a:avLst>
           </a:prstGeom>
           <a:solidFill>
@@ -10607,7 +10631,7 @@
         <p:spPr>
           <a:xfrm>
             <a:off x="7680960" y="1737360"/>
-            <a:ext cx="3794760" cy="1645920"/>
+            <a:ext cx="3794760" cy="1005840"/>
           </a:xfrm>
           <a:prstGeom prst="rect">
             <a:avLst/>
@@ -10674,15 +10698,39 @@
           </a:p>
         </p:txBody>
       </p:sp>
-      <p:sp>
-        <p:nvSpPr>
-          <p:cNvPr id="8" name="Rounded Rectangle 7"/>
+      <p:pic>
+        <p:nvPicPr>
+          <p:cNvPr id="8" name="Picture 7" descr="always-has-been-ru-cost.jpg"/>
+          <p:cNvPicPr>
+            <a:picLocks noChangeAspect="1"/>
+          </p:cNvPicPr>
+          <p:nvPr/>
+        </p:nvPicPr>
+        <p:blipFill>
+          <a:blip r:embed="rId3"/>
+          <a:stretch>
+            <a:fillRect/>
+          </a:stretch>
+        </p:blipFill>
+        <p:spPr>
+          <a:xfrm>
+            <a:off x="8318499" y="2944368"/>
+            <a:ext cx="2519680" cy="1417320"/>
+          </a:xfrm>
+          <a:prstGeom prst="rect">
+            <a:avLst/>
+          </a:prstGeom>
+        </p:spPr>
+      </p:pic>
+      <p:sp>
+        <p:nvSpPr>
+          <p:cNvPr id="9" name="Rounded Rectangle 8"/>
           <p:cNvSpPr/>
           <p:nvPr/>
         </p:nvSpPr>
         <p:spPr>
           <a:xfrm>
-            <a:off x="7452360" y="3794760"/>
+            <a:off x="7452360" y="4617720"/>
             <a:ext cx="4251960" cy="2148840"/>
           </a:xfrm>
           <a:prstGeom prst="roundRect">
@@ -10724,13 +10772,13 @@
       </p:sp>
       <p:sp>
         <p:nvSpPr>
-          <p:cNvPr id="9" name="TextBox 8"/>
+          <p:cNvPr id="10" name="TextBox 9"/>
           <p:cNvSpPr txBox="1"/>
           <p:nvPr/>
         </p:nvSpPr>
         <p:spPr>
           <a:xfrm>
-            <a:off x="7662672" y="3950208"/>
+            <a:off x="7662672" y="4773168"/>
             <a:ext cx="3840480" cy="1874519"/>
           </a:xfrm>
           <a:prstGeom prst="rect">
@@ -10801,7 +10849,7 @@
       </p:sp>
       <p:sp>
         <p:nvSpPr>
-          <p:cNvPr id="10" name="TextBox 9"/>
+          <p:cNvPr id="11" name="TextBox 10"/>
           <p:cNvSpPr txBox="1"/>
           <p:nvPr/>
         </p:nvSpPr>
@@ -16250,7 +16298,7 @@
         <p:spPr>
           <a:xfrm>
             <a:off x="7360920" y="1554480"/>
-            <a:ext cx="4343400" cy="2377440"/>
+            <a:ext cx="4343400" cy="1536192"/>
           </a:xfrm>
           <a:prstGeom prst="roundRect">
             <a:avLst>
@@ -16297,8 +16345,8 @@
         </p:nvSpPr>
         <p:spPr>
           <a:xfrm>
-            <a:off x="7635240" y="1783080"/>
-            <a:ext cx="3840480" cy="1920240"/>
+            <a:off x="7635240" y="1682496"/>
+            <a:ext cx="3840480" cy="1325880"/>
           </a:xfrm>
           <a:prstGeom prst="rect">
             <a:avLst/>
@@ -16383,7 +16431,7 @@
         </p:nvSpPr>
         <p:spPr>
           <a:xfrm>
-            <a:off x="7360920" y="4114800"/>
+            <a:off x="7360920" y="3145536"/>
             <a:ext cx="4343400" cy="320040"/>
           </a:xfrm>
           <a:prstGeom prst="rect">
@@ -16417,6 +16465,78 @@
       <p:sp>
         <p:nvSpPr>
           <p:cNvPr id="7" name="Rounded Rectangle 6"/>
+          <p:cNvSpPr/>
+          <p:nvPr/>
+        </p:nvSpPr>
+        <p:spPr>
+          <a:xfrm>
+            <a:off x="7360920" y="3493008"/>
+            <a:ext cx="4343400" cy="2212848"/>
+          </a:xfrm>
+          <a:prstGeom prst="roundRect">
+            <a:avLst>
+              <a:gd name="adj" fmla="val 13774"/>
+            </a:avLst>
+          </a:prstGeom>
+          <a:solidFill>
+            <a:srgbClr val="FFFFFF"/>
+          </a:solidFill>
+          <a:ln w="16510">
+            <a:solidFill>
+              <a:srgbClr val="1C7293"/>
+            </a:solidFill>
+          </a:ln>
+          <a:effectLst/>
+        </p:spPr>
+        <p:style>
+          <a:lnRef idx="1">
+            <a:schemeClr val="accent1"/>
+          </a:lnRef>
+          <a:fillRef idx="3">
+            <a:schemeClr val="accent1"/>
+          </a:fillRef>
+          <a:effectRef idx="2">
+            <a:schemeClr val="accent1"/>
+          </a:effectRef>
+          <a:fontRef idx="minor">
+            <a:schemeClr val="lt1"/>
+          </a:fontRef>
+        </p:style>
+        <p:txBody>
+          <a:bodyPr rtlCol="0" anchor="ctr"/>
+          <a:lstStyle/>
+          <a:p>
+            <a:pPr algn="ctr"/>
+          </a:p>
+        </p:txBody>
+      </p:sp>
+      <p:pic>
+        <p:nvPicPr>
+          <p:cNvPr id="8" name="Picture 7" descr="spiderman-similarity.jpg"/>
+          <p:cNvPicPr>
+            <a:picLocks noChangeAspect="1"/>
+          </p:cNvPicPr>
+          <p:nvPr/>
+        </p:nvPicPr>
+        <p:blipFill>
+          <a:blip r:embed="rId2"/>
+          <a:stretch>
+            <a:fillRect/>
+          </a:stretch>
+        </p:blipFill>
+        <p:spPr>
+          <a:xfrm>
+            <a:off x="8169984" y="3557016"/>
+            <a:ext cx="2725270" cy="2084832"/>
+          </a:xfrm>
+          <a:prstGeom prst="rect">
+            <a:avLst/>
+          </a:prstGeom>
+        </p:spPr>
+      </p:pic>
+      <p:sp>
+        <p:nvSpPr>
+          <p:cNvPr id="9" name="Rounded Rectangle 8"/>
           <p:cNvSpPr/>
           <p:nvPr/>
         </p:nvSpPr>
@@ -16464,7 +16584,7 @@
       </p:sp>
       <p:sp>
         <p:nvSpPr>
-          <p:cNvPr id="8" name="TextBox 7"/>
+          <p:cNvPr id="10" name="TextBox 9"/>
           <p:cNvSpPr txBox="1"/>
           <p:nvPr/>
         </p:nvSpPr>
@@ -16503,7 +16623,7 @@
       </p:sp>
       <p:sp>
         <p:nvSpPr>
-          <p:cNvPr id="9" name="TextBox 8"/>
+          <p:cNvPr id="11" name="TextBox 10"/>
           <p:cNvSpPr txBox="1"/>
           <p:nvPr/>
         </p:nvSpPr>
@@ -25807,7 +25927,7 @@
         <p:spPr>
           <a:xfrm>
             <a:off x="777240" y="4114800"/>
-            <a:ext cx="4206240" cy="292608"/>
+            <a:ext cx="2834640" cy="292608"/>
           </a:xfrm>
           <a:prstGeom prst="rect">
             <a:avLst/>
@@ -25850,8 +25970,8 @@
         </p:nvSpPr>
         <p:spPr>
           <a:xfrm>
-            <a:off x="5074920" y="4114800"/>
-            <a:ext cx="1188720" cy="292608"/>
+            <a:off x="3703320" y="4114800"/>
+            <a:ext cx="1005840" cy="292608"/>
           </a:xfrm>
           <a:prstGeom prst="rect">
             <a:avLst/>
@@ -25890,7 +26010,7 @@
         <p:spPr>
           <a:xfrm>
             <a:off x="896112" y="4133087"/>
-            <a:ext cx="3291840" cy="256032"/>
+            <a:ext cx="2651760" cy="256032"/>
           </a:xfrm>
           <a:prstGeom prst="rect">
             <a:avLst/>
@@ -25929,7 +26049,7 @@
         <p:spPr>
           <a:xfrm>
             <a:off x="777240" y="4498848"/>
-            <a:ext cx="749808" cy="292608"/>
+            <a:ext cx="502920" cy="292608"/>
           </a:xfrm>
           <a:prstGeom prst="rect">
             <a:avLst/>
@@ -25972,8 +26092,8 @@
         </p:nvSpPr>
         <p:spPr>
           <a:xfrm>
-            <a:off x="1645920" y="4498848"/>
-            <a:ext cx="4480560" cy="292608"/>
+            <a:off x="1371600" y="4498848"/>
+            <a:ext cx="3291840" cy="292608"/>
           </a:xfrm>
           <a:prstGeom prst="rect">
             <a:avLst/>
@@ -26012,9 +26132,33 @@
           </a:p>
         </p:txBody>
       </p:sp>
-      <p:sp>
-        <p:nvSpPr>
-          <p:cNvPr id="17" name="Rounded Rectangle 16"/>
+      <p:pic>
+        <p:nvPicPr>
+          <p:cNvPr id="17" name="Picture 16" descr="stonks-template.png"/>
+          <p:cNvPicPr>
+            <a:picLocks noChangeAspect="1"/>
+          </p:cNvPicPr>
+          <p:nvPr/>
+        </p:nvPicPr>
+        <p:blipFill>
+          <a:blip r:embed="rId2"/>
+          <a:stretch>
+            <a:fillRect/>
+          </a:stretch>
+        </p:blipFill>
+        <p:spPr>
+          <a:xfrm>
+            <a:off x="4709160" y="3983126"/>
+            <a:ext cx="1508760" cy="1132027"/>
+          </a:xfrm>
+          <a:prstGeom prst="rect">
+            <a:avLst/>
+          </a:prstGeom>
+        </p:spPr>
+      </p:pic>
+      <p:sp>
+        <p:nvSpPr>
+          <p:cNvPr id="18" name="Rounded Rectangle 17"/>
           <p:cNvSpPr/>
           <p:nvPr/>
         </p:nvSpPr>
@@ -26062,7 +26206,7 @@
       </p:sp>
       <p:sp>
         <p:nvSpPr>
-          <p:cNvPr id="18" name="TextBox 17"/>
+          <p:cNvPr id="19" name="TextBox 18"/>
           <p:cNvSpPr txBox="1"/>
           <p:nvPr/>
         </p:nvSpPr>
@@ -26110,7 +26254,7 @@
       </p:sp>
       <p:sp>
         <p:nvSpPr>
-          <p:cNvPr id="19" name="Rounded Rectangle 18"/>
+          <p:cNvPr id="20" name="Rounded Rectangle 19"/>
           <p:cNvSpPr/>
           <p:nvPr/>
         </p:nvSpPr>
@@ -26158,7 +26302,7 @@
       </p:sp>
       <p:sp>
         <p:nvSpPr>
-          <p:cNvPr id="20" name="TextBox 19"/>
+          <p:cNvPr id="21" name="TextBox 20"/>
           <p:cNvSpPr txBox="1"/>
           <p:nvPr/>
         </p:nvSpPr>
@@ -26197,7 +26341,7 @@
       </p:sp>
       <p:sp>
         <p:nvSpPr>
-          <p:cNvPr id="21" name="TextBox 20"/>
+          <p:cNvPr id="22" name="TextBox 21"/>
           <p:cNvSpPr txBox="1"/>
           <p:nvPr/>
         </p:nvSpPr>
@@ -26236,7 +26380,7 @@
       </p:sp>
       <p:sp>
         <p:nvSpPr>
-          <p:cNvPr id="22" name="Rounded Rectangle 21"/>
+          <p:cNvPr id="23" name="Rounded Rectangle 22"/>
           <p:cNvSpPr/>
           <p:nvPr/>
         </p:nvSpPr>
@@ -26284,7 +26428,7 @@
       </p:sp>
       <p:sp>
         <p:nvSpPr>
-          <p:cNvPr id="23" name="TextBox 22"/>
+          <p:cNvPr id="24" name="TextBox 23"/>
           <p:cNvSpPr txBox="1"/>
           <p:nvPr/>
         </p:nvSpPr>
@@ -26323,7 +26467,7 @@
       </p:sp>
       <p:sp>
         <p:nvSpPr>
-          <p:cNvPr id="24" name="TextBox 23"/>
+          <p:cNvPr id="25" name="TextBox 24"/>
           <p:cNvSpPr txBox="1"/>
           <p:nvPr/>
         </p:nvSpPr>
@@ -26362,7 +26506,7 @@
       </p:sp>
       <p:sp>
         <p:nvSpPr>
-          <p:cNvPr id="25" name="Rounded Rectangle 24"/>
+          <p:cNvPr id="26" name="Rounded Rectangle 25"/>
           <p:cNvSpPr/>
           <p:nvPr/>
         </p:nvSpPr>
@@ -26410,7 +26554,7 @@
       </p:sp>
       <p:sp>
         <p:nvSpPr>
-          <p:cNvPr id="26" name="TextBox 25"/>
+          <p:cNvPr id="27" name="TextBox 26"/>
           <p:cNvSpPr txBox="1"/>
           <p:nvPr/>
         </p:nvSpPr>
@@ -26449,7 +26593,7 @@
       </p:sp>
       <p:sp>
         <p:nvSpPr>
-          <p:cNvPr id="27" name="TextBox 26"/>
+          <p:cNvPr id="28" name="TextBox 27"/>
           <p:cNvSpPr txBox="1"/>
           <p:nvPr/>
         </p:nvSpPr>
@@ -26488,7 +26632,7 @@
       </p:sp>
       <p:sp>
         <p:nvSpPr>
-          <p:cNvPr id="28" name="Rounded Rectangle 27"/>
+          <p:cNvPr id="29" name="Rounded Rectangle 28"/>
           <p:cNvSpPr/>
           <p:nvPr/>
         </p:nvSpPr>
@@ -26536,7 +26680,7 @@
       </p:sp>
       <p:sp>
         <p:nvSpPr>
-          <p:cNvPr id="29" name="TextBox 28"/>
+          <p:cNvPr id="30" name="TextBox 29"/>
           <p:cNvSpPr txBox="1"/>
           <p:nvPr/>
         </p:nvSpPr>
@@ -26575,7 +26719,7 @@
       </p:sp>
       <p:sp>
         <p:nvSpPr>
-          <p:cNvPr id="30" name="TextBox 29"/>
+          <p:cNvPr id="31" name="TextBox 30"/>
           <p:cNvSpPr txBox="1"/>
           <p:nvPr/>
         </p:nvSpPr>
@@ -26614,7 +26758,7 @@
       </p:sp>
       <p:sp>
         <p:nvSpPr>
-          <p:cNvPr id="31" name="Rounded Rectangle 30"/>
+          <p:cNvPr id="32" name="Rounded Rectangle 31"/>
           <p:cNvSpPr/>
           <p:nvPr/>
         </p:nvSpPr>
@@ -26662,7 +26806,7 @@
       </p:sp>
       <p:sp>
         <p:nvSpPr>
-          <p:cNvPr id="32" name="TextBox 31"/>
+          <p:cNvPr id="33" name="TextBox 32"/>
           <p:cNvSpPr txBox="1"/>
           <p:nvPr/>
         </p:nvSpPr>
@@ -26701,7 +26845,7 @@
       </p:sp>
       <p:sp>
         <p:nvSpPr>
-          <p:cNvPr id="33" name="TextBox 32"/>
+          <p:cNvPr id="34" name="TextBox 33"/>
           <p:cNvSpPr txBox="1"/>
           <p:nvPr/>
         </p:nvSpPr>
@@ -26740,7 +26884,7 @@
       </p:sp>
       <p:sp>
         <p:nvSpPr>
-          <p:cNvPr id="34" name="TextBox 33"/>
+          <p:cNvPr id="35" name="TextBox 34"/>
           <p:cNvSpPr txBox="1"/>
           <p:nvPr/>
         </p:nvSpPr>
@@ -26779,7 +26923,7 @@
       </p:sp>
       <p:sp>
         <p:nvSpPr>
-          <p:cNvPr id="35" name="Rounded Rectangle 34"/>
+          <p:cNvPr id="36" name="Rounded Rectangle 35"/>
           <p:cNvSpPr/>
           <p:nvPr/>
         </p:nvSpPr>
@@ -26827,7 +26971,7 @@
       </p:sp>
       <p:sp>
         <p:nvSpPr>
-          <p:cNvPr id="36" name="TextBox 35"/>
+          <p:cNvPr id="37" name="TextBox 36"/>
           <p:cNvSpPr txBox="1"/>
           <p:nvPr/>
         </p:nvSpPr>
@@ -26866,7 +27010,7 @@
       </p:sp>
       <p:sp>
         <p:nvSpPr>
-          <p:cNvPr id="37" name="TextBox 36"/>
+          <p:cNvPr id="38" name="TextBox 37"/>
           <p:cNvSpPr txBox="1"/>
           <p:nvPr/>
         </p:nvSpPr>
@@ -29288,8 +29432,8 @@
         </p:nvSpPr>
         <p:spPr>
           <a:xfrm>
-            <a:off x="6720840" y="1572768"/>
-            <a:ext cx="4709160" cy="1463040"/>
+            <a:off x="6675120" y="1481328"/>
+            <a:ext cx="2487168" cy="1600200"/>
           </a:xfrm>
           <a:prstGeom prst="rect">
             <a:avLst/>
@@ -29304,11 +29448,11 @@
           <a:p>
             <a:pPr algn="l">
               <a:lnSpc>
-                <a:spcPct val="120000"/>
+                <a:spcPct val="118000"/>
               </a:lnSpc>
             </a:pPr>
             <a:r>
-              <a:rPr sz="1250" b="0" i="0">
+              <a:rPr sz="1200" b="0" i="0">
                 <a:solidFill>
                   <a:srgbClr val="21295C"/>
                 </a:solidFill>
@@ -29317,7 +29461,7 @@
               <a:t>U-кривая 2023 распрямилась: </a:t>
             </a:r>
             <a:r>
-              <a:rPr sz="1250" b="1" i="0">
+              <a:rPr sz="1200" b="1" i="0">
                 <a:solidFill>
                   <a:srgbClr val="21295C"/>
                 </a:solidFill>
@@ -29326,7 +29470,7 @@
               <a:t>single-needle — до 99% на полном окне 1 млн</a:t>
             </a:r>
             <a:r>
-              <a:rPr sz="1250" b="0" i="0">
+              <a:rPr sz="1200" b="0" i="0">
                 <a:solidFill>
                   <a:srgbClr val="21295C"/>
                 </a:solidFill>
@@ -29340,6 +29484,78 @@
       <p:sp>
         <p:nvSpPr>
           <p:cNvPr id="7" name="Rounded Rectangle 6"/>
+          <p:cNvSpPr/>
+          <p:nvPr/>
+        </p:nvSpPr>
+        <p:spPr>
+          <a:xfrm>
+            <a:off x="9217152" y="1389888"/>
+            <a:ext cx="2450592" cy="1700784"/>
+          </a:xfrm>
+          <a:prstGeom prst="roundRect">
+            <a:avLst>
+              <a:gd name="adj" fmla="val 17921"/>
+            </a:avLst>
+          </a:prstGeom>
+          <a:solidFill>
+            <a:srgbClr val="FFFFFF"/>
+          </a:solidFill>
+          <a:ln w="15240">
+            <a:solidFill>
+              <a:srgbClr val="1C7293"/>
+            </a:solidFill>
+          </a:ln>
+          <a:effectLst/>
+        </p:spPr>
+        <p:style>
+          <a:lnRef idx="1">
+            <a:schemeClr val="accent1"/>
+          </a:lnRef>
+          <a:fillRef idx="3">
+            <a:schemeClr val="accent1"/>
+          </a:fillRef>
+          <a:effectRef idx="2">
+            <a:schemeClr val="accent1"/>
+          </a:effectRef>
+          <a:fontRef idx="minor">
+            <a:schemeClr val="lt1"/>
+          </a:fontRef>
+        </p:style>
+        <p:txBody>
+          <a:bodyPr rtlCol="0" anchor="ctr"/>
+          <a:lstStyle/>
+          <a:p>
+            <a:pPr algn="ctr"/>
+          </a:p>
+        </p:txBody>
+      </p:sp>
+      <p:pic>
+        <p:nvPicPr>
+          <p:cNvPr id="8" name="Picture 7" descr="needle-haystack-crop.jpg"/>
+          <p:cNvPicPr>
+            <a:picLocks noChangeAspect="1"/>
+          </p:cNvPicPr>
+          <p:nvPr/>
+        </p:nvPicPr>
+        <p:blipFill>
+          <a:blip r:embed="rId3"/>
+          <a:stretch>
+            <a:fillRect/>
+          </a:stretch>
+        </p:blipFill>
+        <p:spPr>
+          <a:xfrm>
+            <a:off x="9314641" y="1444752"/>
+            <a:ext cx="2255612" cy="1591055"/>
+          </a:xfrm>
+          <a:prstGeom prst="rect">
+            <a:avLst/>
+          </a:prstGeom>
+        </p:spPr>
+      </p:pic>
+      <p:sp>
+        <p:nvSpPr>
+          <p:cNvPr id="9" name="Rounded Rectangle 8"/>
           <p:cNvSpPr/>
           <p:nvPr/>
         </p:nvSpPr>
@@ -29387,7 +29603,7 @@
       </p:sp>
       <p:sp>
         <p:nvSpPr>
-          <p:cNvPr id="8" name="TextBox 7"/>
+          <p:cNvPr id="10" name="TextBox 9"/>
           <p:cNvSpPr txBox="1"/>
           <p:nvPr/>
         </p:nvSpPr>
@@ -29435,14 +29651,14 @@
       </p:sp>
       <p:pic>
         <p:nvPicPr>
-          <p:cNvPr id="9" name="Picture 8" descr="s25-nolima.png"/>
+          <p:cNvPr id="11" name="Picture 10" descr="s25-nolima.png"/>
           <p:cNvPicPr>
             <a:picLocks noChangeAspect="1"/>
           </p:cNvPicPr>
           <p:nvPr/>
         </p:nvPicPr>
         <p:blipFill>
-          <a:blip r:embed="rId3"/>
+          <a:blip r:embed="rId4"/>
           <a:stretch>
             <a:fillRect/>
           </a:stretch>
@@ -29459,7 +29675,7 @@
       </p:pic>
       <p:sp>
         <p:nvSpPr>
-          <p:cNvPr id="10" name="TextBox 9"/>
+          <p:cNvPr id="12" name="TextBox 11"/>
           <p:cNvSpPr txBox="1"/>
           <p:nvPr/>
         </p:nvSpPr>
@@ -29535,7 +29751,7 @@
       </p:sp>
       <p:sp>
         <p:nvSpPr>
-          <p:cNvPr id="11" name="Rounded Rectangle 10"/>
+          <p:cNvPr id="13" name="Rounded Rectangle 12"/>
           <p:cNvSpPr/>
           <p:nvPr/>
         </p:nvSpPr>
@@ -29583,7 +29799,7 @@
       </p:sp>
       <p:sp>
         <p:nvSpPr>
-          <p:cNvPr id="12" name="TextBox 11"/>
+          <p:cNvPr id="14" name="TextBox 13"/>
           <p:cNvSpPr txBox="1"/>
           <p:nvPr/>
         </p:nvSpPr>
@@ -29622,7 +29838,7 @@
       </p:sp>
       <p:sp>
         <p:nvSpPr>
-          <p:cNvPr id="13" name="TextBox 12"/>
+          <p:cNvPr id="15" name="TextBox 14"/>
           <p:cNvSpPr txBox="1"/>
           <p:nvPr/>
         </p:nvSpPr>
@@ -37721,8 +37937,8 @@
         </p:nvSpPr>
         <p:spPr>
           <a:xfrm>
-            <a:off x="2423160" y="5532120"/>
-            <a:ext cx="7315200" cy="594360"/>
+            <a:off x="502920" y="5623560"/>
+            <a:ext cx="7863840" cy="594360"/>
           </a:xfrm>
           <a:prstGeom prst="roundRect">
             <a:avLst>
@@ -37769,8 +37985,8 @@
         </p:nvSpPr>
         <p:spPr>
           <a:xfrm>
-            <a:off x="2606040" y="5532120"/>
-            <a:ext cx="6949440" cy="594360"/>
+            <a:off x="685800" y="5623560"/>
+            <a:ext cx="7498079" cy="594360"/>
           </a:xfrm>
           <a:prstGeom prst="rect">
             <a:avLst/>
@@ -37809,9 +38025,33 @@
           </a:p>
         </p:txBody>
       </p:sp>
-      <p:sp>
-        <p:nvSpPr>
-          <p:cNvPr id="27" name="TextBox 26"/>
+      <p:pic>
+        <p:nvPicPr>
+          <p:cNvPr id="27" name="Picture 26" descr="gandalf-token.jpg"/>
+          <p:cNvPicPr>
+            <a:picLocks noChangeAspect="1"/>
+          </p:cNvPicPr>
+          <p:nvPr/>
+        </p:nvPicPr>
+        <p:blipFill>
+          <a:blip r:embed="rId2"/>
+          <a:stretch>
+            <a:fillRect/>
+          </a:stretch>
+        </p:blipFill>
+        <p:spPr>
+          <a:xfrm>
+            <a:off x="8747655" y="5413248"/>
+            <a:ext cx="2621488" cy="1280160"/>
+          </a:xfrm>
+          <a:prstGeom prst="rect">
+            <a:avLst/>
+          </a:prstGeom>
+        </p:spPr>
+      </p:pic>
+      <p:sp>
+        <p:nvSpPr>
+          <p:cNvPr id="28" name="TextBox 27"/>
           <p:cNvSpPr txBox="1"/>
           <p:nvPr/>
         </p:nvSpPr>
@@ -39864,9 +40104,33 @@
           </a:p>
         </p:txBody>
       </p:sp>
-      <p:sp>
-        <p:nvSpPr>
-          <p:cNvPr id="13" name="TextBox 12"/>
+      <p:pic>
+        <p:nvPicPr>
+          <p:cNvPr id="13" name="Picture 12" descr="joker-burning-money.jpg"/>
+          <p:cNvPicPr>
+            <a:picLocks noChangeAspect="1"/>
+          </p:cNvPicPr>
+          <p:nvPr/>
+        </p:nvPicPr>
+        <p:blipFill>
+          <a:blip r:embed="rId2"/>
+          <a:stretch>
+            <a:fillRect/>
+          </a:stretch>
+        </p:blipFill>
+        <p:spPr>
+          <a:xfrm>
+            <a:off x="9705456" y="1298448"/>
+            <a:ext cx="1748302" cy="978408"/>
+          </a:xfrm>
+          <a:prstGeom prst="rect">
+            <a:avLst/>
+          </a:prstGeom>
+        </p:spPr>
+      </p:pic>
+      <p:sp>
+        <p:nvSpPr>
+          <p:cNvPr id="14" name="TextBox 13"/>
           <p:cNvSpPr txBox="1"/>
           <p:nvPr/>
         </p:nvSpPr>
@@ -39905,7 +40169,7 @@
       </p:sp>
       <p:sp>
         <p:nvSpPr>
-          <p:cNvPr id="14" name="Rounded Rectangle 13"/>
+          <p:cNvPr id="15" name="Rounded Rectangle 14"/>
           <p:cNvSpPr/>
           <p:nvPr/>
         </p:nvSpPr>
@@ -39953,7 +40217,7 @@
       </p:sp>
       <p:sp>
         <p:nvSpPr>
-          <p:cNvPr id="15" name="TextBox 14"/>
+          <p:cNvPr id="16" name="TextBox 15"/>
           <p:cNvSpPr txBox="1"/>
           <p:nvPr/>
         </p:nvSpPr>
@@ -39992,7 +40256,7 @@
       </p:sp>
       <p:sp>
         <p:nvSpPr>
-          <p:cNvPr id="16" name="Rounded Rectangle 15"/>
+          <p:cNvPr id="17" name="Rounded Rectangle 16"/>
           <p:cNvSpPr/>
           <p:nvPr/>
         </p:nvSpPr>
@@ -40038,7 +40302,7 @@
       </p:sp>
       <p:sp>
         <p:nvSpPr>
-          <p:cNvPr id="17" name="TextBox 16"/>
+          <p:cNvPr id="18" name="TextBox 17"/>
           <p:cNvSpPr txBox="1"/>
           <p:nvPr/>
         </p:nvSpPr>
@@ -40077,7 +40341,7 @@
       </p:sp>
       <p:sp>
         <p:nvSpPr>
-          <p:cNvPr id="18" name="TextBox 17"/>
+          <p:cNvPr id="19" name="TextBox 18"/>
           <p:cNvSpPr txBox="1"/>
           <p:nvPr/>
         </p:nvSpPr>
@@ -40116,7 +40380,7 @@
       </p:sp>
       <p:sp>
         <p:nvSpPr>
-          <p:cNvPr id="19" name="Rounded Rectangle 18"/>
+          <p:cNvPr id="20" name="Rounded Rectangle 19"/>
           <p:cNvSpPr/>
           <p:nvPr/>
         </p:nvSpPr>
@@ -40162,7 +40426,7 @@
       </p:sp>
       <p:sp>
         <p:nvSpPr>
-          <p:cNvPr id="20" name="TextBox 19"/>
+          <p:cNvPr id="21" name="TextBox 20"/>
           <p:cNvSpPr txBox="1"/>
           <p:nvPr/>
         </p:nvSpPr>
@@ -40201,7 +40465,7 @@
       </p:sp>
       <p:sp>
         <p:nvSpPr>
-          <p:cNvPr id="21" name="TextBox 20"/>
+          <p:cNvPr id="22" name="TextBox 21"/>
           <p:cNvSpPr txBox="1"/>
           <p:nvPr/>
         </p:nvSpPr>
@@ -40240,7 +40504,7 @@
       </p:sp>
       <p:sp>
         <p:nvSpPr>
-          <p:cNvPr id="22" name="Rounded Rectangle 21"/>
+          <p:cNvPr id="23" name="Rounded Rectangle 22"/>
           <p:cNvSpPr/>
           <p:nvPr/>
         </p:nvSpPr>
@@ -40286,7 +40550,7 @@
       </p:sp>
       <p:sp>
         <p:nvSpPr>
-          <p:cNvPr id="23" name="TextBox 22"/>
+          <p:cNvPr id="24" name="TextBox 23"/>
           <p:cNvSpPr txBox="1"/>
           <p:nvPr/>
         </p:nvSpPr>
@@ -40325,7 +40589,7 @@
       </p:sp>
       <p:sp>
         <p:nvSpPr>
-          <p:cNvPr id="24" name="TextBox 23"/>
+          <p:cNvPr id="25" name="TextBox 24"/>
           <p:cNvSpPr txBox="1"/>
           <p:nvPr/>
         </p:nvSpPr>
@@ -40373,7 +40637,7 @@
       </p:sp>
       <p:sp>
         <p:nvSpPr>
-          <p:cNvPr id="25" name="Rounded Rectangle 24"/>
+          <p:cNvPr id="26" name="Rounded Rectangle 25"/>
           <p:cNvSpPr/>
           <p:nvPr/>
         </p:nvSpPr>
@@ -40421,7 +40685,7 @@
       </p:sp>
       <p:sp>
         <p:nvSpPr>
-          <p:cNvPr id="26" name="TextBox 25"/>
+          <p:cNvPr id="27" name="TextBox 26"/>
           <p:cNvSpPr txBox="1"/>
           <p:nvPr/>
         </p:nvSpPr>
@@ -40469,7 +40733,7 @@
       </p:sp>
       <p:sp>
         <p:nvSpPr>
-          <p:cNvPr id="27" name="Rounded Rectangle 26"/>
+          <p:cNvPr id="28" name="Rounded Rectangle 27"/>
           <p:cNvSpPr/>
           <p:nvPr/>
         </p:nvSpPr>
@@ -40517,7 +40781,7 @@
       </p:sp>
       <p:sp>
         <p:nvSpPr>
-          <p:cNvPr id="28" name="TextBox 27"/>
+          <p:cNvPr id="29" name="TextBox 28"/>
           <p:cNvSpPr txBox="1"/>
           <p:nvPr/>
         </p:nvSpPr>
@@ -40565,7 +40829,7 @@
       </p:sp>
       <p:sp>
         <p:nvSpPr>
-          <p:cNvPr id="29" name="Rounded Rectangle 28"/>
+          <p:cNvPr id="30" name="Rounded Rectangle 29"/>
           <p:cNvSpPr/>
           <p:nvPr/>
         </p:nvSpPr>
@@ -40613,7 +40877,7 @@
       </p:sp>
       <p:sp>
         <p:nvSpPr>
-          <p:cNvPr id="30" name="TextBox 29"/>
+          <p:cNvPr id="31" name="TextBox 30"/>
           <p:cNvSpPr txBox="1"/>
           <p:nvPr/>
         </p:nvSpPr>
@@ -40652,7 +40916,7 @@
       </p:sp>
       <p:sp>
         <p:nvSpPr>
-          <p:cNvPr id="31" name="TextBox 30"/>
+          <p:cNvPr id="32" name="TextBox 31"/>
           <p:cNvSpPr txBox="1"/>
           <p:nvPr/>
         </p:nvSpPr>
@@ -45881,7 +46145,7 @@
         <p:spPr>
           <a:xfrm>
             <a:off x="1325880" y="3282696"/>
-            <a:ext cx="10058400" cy="777240"/>
+            <a:ext cx="7406640" cy="777240"/>
           </a:xfrm>
           <a:prstGeom prst="rect">
             <a:avLst/>
@@ -45929,9 +46193,33 @@
           </a:p>
         </p:txBody>
       </p:sp>
-      <p:sp>
-        <p:nvSpPr>
-          <p:cNvPr id="13" name="Rounded Rectangle 12"/>
+      <p:pic>
+        <p:nvPicPr>
+          <p:cNvPr id="13" name="Picture 12" descr="pressx-template.jpg"/>
+          <p:cNvPicPr>
+            <a:picLocks noChangeAspect="1"/>
+          </p:cNvPicPr>
+          <p:nvPr/>
+        </p:nvPicPr>
+        <p:blipFill>
+          <a:blip r:embed="rId2"/>
+          <a:stretch>
+            <a:fillRect/>
+          </a:stretch>
+        </p:blipFill>
+        <p:spPr>
+          <a:xfrm>
+            <a:off x="9315196" y="2871216"/>
+            <a:ext cx="2080768" cy="1170432"/>
+          </a:xfrm>
+          <a:prstGeom prst="rect">
+            <a:avLst/>
+          </a:prstGeom>
+        </p:spPr>
+      </p:pic>
+      <p:sp>
+        <p:nvSpPr>
+          <p:cNvPr id="14" name="Rounded Rectangle 13"/>
           <p:cNvSpPr/>
           <p:nvPr/>
         </p:nvSpPr>
@@ -45979,7 +46267,7 @@
       </p:sp>
       <p:sp>
         <p:nvSpPr>
-          <p:cNvPr id="14" name="TextBox 13"/>
+          <p:cNvPr id="15" name="TextBox 14"/>
           <p:cNvSpPr txBox="1"/>
           <p:nvPr/>
         </p:nvSpPr>
@@ -46018,7 +46306,7 @@
       </p:sp>
       <p:sp>
         <p:nvSpPr>
-          <p:cNvPr id="15" name="TextBox 14"/>
+          <p:cNvPr id="16" name="TextBox 15"/>
           <p:cNvSpPr txBox="1"/>
           <p:nvPr/>
         </p:nvSpPr>
@@ -46057,7 +46345,7 @@
       </p:sp>
       <p:sp>
         <p:nvSpPr>
-          <p:cNvPr id="16" name="TextBox 15"/>
+          <p:cNvPr id="17" name="TextBox 16"/>
           <p:cNvSpPr txBox="1"/>
           <p:nvPr/>
         </p:nvSpPr>
@@ -46132,7 +46420,7 @@
       </p:sp>
       <p:sp>
         <p:nvSpPr>
-          <p:cNvPr id="17" name="Rounded Rectangle 16"/>
+          <p:cNvPr id="18" name="Rounded Rectangle 17"/>
           <p:cNvSpPr/>
           <p:nvPr/>
         </p:nvSpPr>
@@ -46180,7 +46468,7 @@
       </p:sp>
       <p:sp>
         <p:nvSpPr>
-          <p:cNvPr id="18" name="TextBox 17"/>
+          <p:cNvPr id="19" name="TextBox 18"/>
           <p:cNvSpPr txBox="1"/>
           <p:nvPr/>
         </p:nvSpPr>
@@ -46219,7 +46507,7 @@
       </p:sp>
       <p:sp>
         <p:nvSpPr>
-          <p:cNvPr id="19" name="TextBox 18"/>
+          <p:cNvPr id="20" name="TextBox 19"/>
           <p:cNvSpPr txBox="1"/>
           <p:nvPr/>
         </p:nvSpPr>
@@ -50694,7 +50982,7 @@
         </p:nvSpPr>
         <p:spPr>
           <a:xfrm>
-            <a:off x="9418320" y="2057400"/>
+            <a:off x="9418320" y="1691640"/>
             <a:ext cx="2057400" cy="731520"/>
           </a:xfrm>
           <a:prstGeom prst="roundRect">
@@ -50740,7 +51028,7 @@
         </p:nvSpPr>
         <p:spPr>
           <a:xfrm>
-            <a:off x="9528048" y="2103120"/>
+            <a:off x="9528048" y="1737360"/>
             <a:ext cx="1828800" cy="640080"/>
           </a:xfrm>
           <a:prstGeom prst="rect">
@@ -50780,7 +51068,7 @@
         </p:nvSpPr>
         <p:spPr>
           <a:xfrm>
-            <a:off x="7909560" y="2926080"/>
+            <a:off x="7909560" y="2560320"/>
             <a:ext cx="3566160" cy="822960"/>
           </a:xfrm>
           <a:prstGeom prst="roundRect">
@@ -50826,7 +51114,7 @@
         </p:nvSpPr>
         <p:spPr>
           <a:xfrm>
-            <a:off x="8046720" y="2971800"/>
+            <a:off x="8046720" y="2606040"/>
             <a:ext cx="3291840" cy="731520"/>
           </a:xfrm>
           <a:prstGeom prst="rect">
@@ -50866,8 +51154,8 @@
         </p:nvSpPr>
         <p:spPr>
           <a:xfrm>
-            <a:off x="7909560" y="4160520"/>
-            <a:ext cx="3566160" cy="1554480"/>
+            <a:off x="7909560" y="3566160"/>
+            <a:ext cx="3566160" cy="1097280"/>
           </a:xfrm>
           <a:prstGeom prst="rect">
             <a:avLst/>
@@ -50962,9 +51250,33 @@
           </a:p>
         </p:txBody>
       </p:sp>
-      <p:sp>
-        <p:nvSpPr>
-          <p:cNvPr id="21" name="TextBox 20"/>
+      <p:pic>
+        <p:nvPicPr>
+          <p:cNvPr id="21" name="Picture 20" descr="twobuttons-llm-vs-code-toponly.jpg"/>
+          <p:cNvPicPr>
+            <a:picLocks noChangeAspect="1"/>
+          </p:cNvPicPr>
+          <p:nvPr/>
+        </p:nvPicPr>
+        <p:blipFill>
+          <a:blip r:embed="rId2"/>
+          <a:stretch>
+            <a:fillRect/>
+          </a:stretch>
+        </p:blipFill>
+        <p:spPr>
+          <a:xfrm>
+            <a:off x="8650224" y="4645152"/>
+            <a:ext cx="2084832" cy="1389888"/>
+          </a:xfrm>
+          <a:prstGeom prst="rect">
+            <a:avLst/>
+          </a:prstGeom>
+        </p:spPr>
+      </p:pic>
+      <p:sp>
+        <p:nvSpPr>
+          <p:cNvPr id="22" name="TextBox 21"/>
           <p:cNvSpPr txBox="1"/>
           <p:nvPr/>
         </p:nvSpPr>
@@ -51908,8 +52220,8 @@
         </p:nvSpPr>
         <p:spPr>
           <a:xfrm>
-            <a:off x="502920" y="4892040"/>
-            <a:ext cx="11201400" cy="868680"/>
+            <a:off x="502920" y="5029200"/>
+            <a:ext cx="6903720" cy="1234440"/>
           </a:xfrm>
           <a:prstGeom prst="roundRect">
             <a:avLst>
@@ -51956,8 +52268,8 @@
         </p:nvSpPr>
         <p:spPr>
           <a:xfrm>
-            <a:off x="685800" y="4946903"/>
-            <a:ext cx="10835640" cy="758952"/>
+            <a:off x="685800" y="5084064"/>
+            <a:ext cx="6537959" cy="1124712"/>
           </a:xfrm>
           <a:prstGeom prst="rect">
             <a:avLst/>
@@ -51987,9 +52299,33 @@
           </a:p>
         </p:txBody>
       </p:sp>
-      <p:sp>
-        <p:nvSpPr>
-          <p:cNvPr id="23" name="TextBox 22"/>
+      <p:pic>
+        <p:nvPicPr>
+          <p:cNvPr id="23" name="Picture 22" descr="xkcd-552-correlation-2x.png"/>
+          <p:cNvPicPr>
+            <a:picLocks noChangeAspect="1"/>
+          </p:cNvPicPr>
+          <p:nvPr/>
+        </p:nvPicPr>
+        <p:blipFill>
+          <a:blip r:embed="rId2"/>
+          <a:stretch>
+            <a:fillRect/>
+          </a:stretch>
+        </p:blipFill>
+        <p:spPr>
+          <a:xfrm>
+            <a:off x="7543800" y="4919472"/>
+            <a:ext cx="4114800" cy="1662953"/>
+          </a:xfrm>
+          <a:prstGeom prst="rect">
+            <a:avLst/>
+          </a:prstGeom>
+        </p:spPr>
+      </p:pic>
+      <p:sp>
+        <p:nvSpPr>
+          <p:cNvPr id="24" name="TextBox 23"/>
           <p:cNvSpPr txBox="1"/>
           <p:nvPr/>
         </p:nvSpPr>

</xml_diff>